<commit_message>
Run Wordzzle on iOS with Xcode 26.6 and record Hot Reload
Add an opt-in .NET 11 Preview 6 Apple toolchain profile with the iOS-26.5-compatible MAUI 11 RC2 package and a scoped mlaunch correction. Preserve the default Android RC2 pins. Publish genuine iOS screenshots, XAML/C# Hot Reload recordings, setup instructions and updated slides.

Co-authored-by: Copilot App <223556219+Copilot@users.noreply.github.com>
</commit_message>
<xml_diff>
--- a/src/Controls/samples/Wordzzle/Wordzzle-hackathon.pptx
+++ b/src/Controls/samples/Wordzzle/Wordzzle-hackathon.pptx
@@ -150,7 +150,7 @@
           <a:lstStyle/>
           <a:p>
             <a:r>
-              <a:t>The SDK and workload were exactly pinned to the event. Android API30 uses CoreCLR. Direct MCP protocol calls verified tree/query/tap/fill/scroll/screenshot/get/set/assert, including intentional assertion failure. A memory-only label change reset on relaunch, separately from real dotnet-watch XAML source Hot Reload. Setup was not frictionless: public-only restore failed for exact event packages, an API36 emulator stayed offline, manually sideloaded fast-deploy APK missed assemblies, and DevFlow needed an explicit ADB forward. Existing authorized event credentials were used only locally. Editor background UI control failed, so do not count these direct tool tests as a MAUI chat-agent pass. See README for final full matrix. The event deck destination was TODO; these two slides are a local handoff, not an uploaded deck.</a:t>
+              <a:t>Actual dotnet watch XAML and C# source edits were recorded on both platforms. iOS PID 12297 and page session 68811798 stayed unchanged: label/color/font changed, counter stayed 3, then the handler changed from +1 to +2 and a tap produced 5. Empty input and the Maui tester greeting passed; a deliberate CS1525 left the app usable and recovery preserved the process/session. Preview 6 MAUI alone applied managed deltas without refreshing XAML UI; the iOS-26.5-compatible RC2 package resolved this. A sample-local target corrects Preview 6's quoted mlaunch executable and run directory. Exact event iOS still requires Xcode 27. VS Code F5, breakpoints, flame-button Hot Reload and MAUI chat-agent selection remain unverified; CLI/MCP recordings are not editor evidence. See README for versions, first failures, video processing and limits.</a:t>
             </a:r>
           </a:p>
         </p:txBody>
@@ -3227,7 +3227,7 @@
                   <a:srgbClr val="30343B"/>
                 </a:solidFill>
               </a:rPr>
-              <a:t>From Xamarin.Forms to a running Android game</a:t>
+              <a:t>Running on Android and iOS - no Xcode 27</a:t>
             </a:r>
           </a:p>
         </p:txBody>
@@ -3461,7 +3461,7 @@
                   <a:srgbClr val="30343B"/>
                 </a:solidFill>
               </a:rPr>
-              <a:t>Working: CoreCLR Android app and real DevFlow MCP</a:t>
+              <a:t>Working: Android + iOS CoreCLR, real DevFlow MCP</a:t>
             </a:r>
           </a:p>
         </p:txBody>
@@ -3525,7 +3525,7 @@
                   <a:srgbClr val="30343B"/>
                 </a:solidFill>
               </a:rPr>
-              <a:t>Setup: exact RC2 feeds; software-rendered emulator</a:t>
+              <a:t>iOS: .NET 11 Preview 6 + compatible MAUI 11 RC2</a:t>
             </a:r>
           </a:p>
         </p:txBody>
@@ -3554,10 +3554,10 @@
             <a:r>
               <a:rPr sz="2200">
                 <a:solidFill>
-                  <a:srgbClr val="A34C28"/>
+                  <a:srgbClr val="538D4E"/>
                 </a:solidFill>
               </a:rPr>
-              <a:t>Blocked: iOS workload requires Xcode 27; host has 26.6</a:t>
+              <a:t>Xcode 26.6; iOS SDK 26.5; two iOS Hot Reload videos</a:t>
             </a:r>
           </a:p>
         </p:txBody>

</xml_diff>

<commit_message>
Record Wordzzle F5 launch and hackathon evidence
Document the verified Android F5 counter and fresh RC2 template launch, preserve the IDE device-picker failure, and record the remaining desktop-locked scenarios honestly. Keep machine-specific launch paths out of Git.

Co-authored-by: Copilot App <223556219+Copilot@users.noreply.github.com>
</commit_message>
<xml_diff>
--- a/src/Controls/samples/Wordzzle/Wordzzle-hackathon.pptx
+++ b/src/Controls/samples/Wordzzle/Wordzzle-hackathon.pptx
@@ -150,7 +150,7 @@
           <a:lstStyle/>
           <a:p>
             <a:r>
-              <a:t>Actual dotnet watch XAML and C# source edits were recorded on both platforms. iOS PID 12297 and page session 68811798 stayed unchanged: label/color/font changed, counter stayed 3, then the handler changed from +1 to +2 and a tap produced 5. Empty input and the Maui tester greeting passed; a deliberate CS1525 left the app usable and recovery preserved the process/session. Preview 6 MAUI alone applied managed deltas without refreshing XAML UI; the iOS-26.5-compatible RC2 package resolved this. A sample-local target corrects Preview 6's quoted mlaunch executable and run directory. Exact event iOS still requires Xcode 27. VS Code F5, breakpoints, flame-button Hot Reload and MAUI chat-agent selection remain unverified; CLI/MCP recordings are not editor evidence. See README for versions, first failures, video processing and limits.</a:t>
+              <a:t>VS Code recovery required dotnet.useLegacyDotnetResolution to normalize the Homebrew runtime path, full-project restore of the event runtime packages, and reload to activate C# Dev Kit 3.40.210. MAUI extension 11.0.24 did not resolve relative or workspace-variable project paths and failed to persist the selected target/platform. An ignored machine-local launch profile with an absolute project path, explicit Android platform/device, and useLaunchJsonConfigurations enabled worked. The IDE showed Debugging started, one active Call Stack session, and C# Hot Reload available. The earlier build-only trial is not counted. The desktop then locked and automation refused input; breakpoint/variables/step/continue, three debugger relaunch cycles, second-device switching, editor Hot Reload/Undo/Redo/error recovery, MAUI-agent prompts and plain-Copilot comparison remain unverified. Existing four Android/iOS Hot Reload videos are CLI evidence, not IDE or agent evidence. The actual VS Code device-picker failure and F5-launched counter image are published in README. No event deck upload: supplied destination was TODO.</a:t>
             </a:r>
           </a:p>
         </p:txBody>
@@ -3355,7 +3355,7 @@
                   <a:srgbClr val="538D4E"/>
                 </a:solidFill>
               </a:rPr>
-              <a:t>Real app screenshots and scenario evidence: README.md</a:t>
+              <a:t>Real app, F5 counter and template captures: README.md</a:t>
             </a:r>
           </a:p>
         </p:txBody>
@@ -3461,7 +3461,7 @@
                   <a:srgbClr val="30343B"/>
                 </a:solidFill>
               </a:rPr>
-              <a:t>Working: Android + iOS CoreCLR, real DevFlow MCP</a:t>
+              <a:t>Android F5 + counter; CLI Hot Reload on both</a:t>
             </a:r>
           </a:p>
         </p:txBody>
@@ -3493,7 +3493,7 @@
                   <a:srgbClr val="30343B"/>
                 </a:solidFill>
               </a:rPr>
-              <a:t>XAML + C# Hot Reload preserve session and counter</a:t>
+              <a:t>IDE recovery: .NET path, restore, launch settings</a:t>
             </a:r>
           </a:p>
         </p:txBody>
@@ -3525,7 +3525,7 @@
                   <a:srgbClr val="30343B"/>
                 </a:solidFill>
               </a:rPr>
-              <a:t>iOS: .NET 11 Preview 6 + compatible MAUI 11 RC2</a:t>
+              <a:t>iOS: Xcode 26.6 + compatible .NET 11 / MAUI RC2</a:t>
             </a:r>
           </a:p>
         </p:txBody>
@@ -3557,7 +3557,7 @@
                   <a:srgbClr val="538D4E"/>
                 </a:solidFill>
               </a:rPr>
-              <a:t>Xcode 26.6; iOS SDK 26.5; two iOS Hot Reload videos</a:t>
+              <a:t>Template runs; real captures + four videos in README</a:t>
             </a:r>
           </a:p>
         </p:txBody>
@@ -3589,7 +3589,7 @@
                   <a:srgbClr val="A34C28"/>
                 </a:solidFill>
               </a:rPr>
-              <a:t>VS Code F5 / agent chat not validated; no false Pass</a:t>
+              <a:t>Blocked: breakpoints, IDE Hot Reload, agent chat</a:t>
             </a:r>
           </a:p>
         </p:txBody>

</xml_diff>